<commit_message>
Azure SQL set up as code (passwordless), one setup script for Mac and Windows, call-out revenue split
- tools/database: create and lock down Azure SQL (Microsoft sign-in only, per-machine firewall, TLS 1.2,
  free serverless tier), least-privilege roles, staged all-or-nothing loads with a load log, and a
  table-by-table guide with star-schema advice and Claude MCP prompts (written to OneDrive).
- tools/setup_machine.py: one command gets the Mac or the Windows PC ready (packages, Azure CLI, git
  noreply + leak guard, OneDrive, sign-in, firewall, connection test).
- tools/githooks: stops any commit containing a password, key, data file or personal detail.
- Report builder can read the database (--source db) and prove it matches the CSVs (--compare-sources).
- Call-outs: technician time charged and materials charged (cost x 1.3) as separate revenue lines,
  ledger accounts, job columns and report numbers. Totals unchanged.

Co-Authored-By: Claude Opus 5.5 <noreply@anthropic.com>
</commit_message>
<xml_diff>
--- a/media/exports/reports/2025-10/job-margins.pptx
+++ b/media/exports/reports/2025-10/job-margins.pptx
@@ -7964,7 +7964,7 @@
         <p:spPr>
           <a:xfrm>
             <a:off x="457200" y="1645920"/>
-            <a:ext cx="11277295" cy="2011680"/>
+            <a:ext cx="3576218" cy="2011680"/>
           </a:xfrm>
           <a:prstGeom prst="rect">
             <a:avLst/>
@@ -8009,7 +8009,7 @@
         <p:spPr>
           <a:xfrm>
             <a:off x="640080" y="1783080"/>
-            <a:ext cx="10911535" cy="457200"/>
+            <a:ext cx="3210458" cy="457200"/>
           </a:xfrm>
           <a:prstGeom prst="rect">
             <a:avLst/>
@@ -8043,7 +8043,7 @@
         <p:spPr>
           <a:xfrm>
             <a:off x="640080" y="2240280"/>
-            <a:ext cx="10911535" cy="731520"/>
+            <a:ext cx="3210458" cy="731520"/>
           </a:xfrm>
           <a:prstGeom prst="rect">
             <a:avLst/>
@@ -8077,7 +8077,7 @@
         <p:spPr>
           <a:xfrm>
             <a:off x="640080" y="3017520"/>
-            <a:ext cx="10911535" cy="548640"/>
+            <a:ext cx="3210458" cy="548640"/>
           </a:xfrm>
           <a:prstGeom prst="rect">
             <a:avLst/>
@@ -8104,7 +8104,301 @@
       </p:sp>
       <p:sp>
         <p:nvSpPr>
-          <p:cNvPr id="9" name="TextBox 8"/>
+          <p:cNvPr id="9" name="Rectangle 8"/>
+          <p:cNvSpPr/>
+          <p:nvPr/>
+        </p:nvSpPr>
+        <p:spPr>
+          <a:xfrm>
+            <a:off x="4307738" y="1645920"/>
+            <a:ext cx="3576218" cy="2011680"/>
+          </a:xfrm>
+          <a:prstGeom prst="rect">
+            <a:avLst/>
+          </a:prstGeom>
+          <a:solidFill>
+            <a:srgbClr val="F7FAF7"/>
+          </a:solidFill>
+          <a:ln>
+            <a:solidFill>
+              <a:srgbClr val="DCE8DC"/>
+            </a:solidFill>
+          </a:ln>
+        </p:spPr>
+        <p:style>
+          <a:lnRef idx="1">
+            <a:schemeClr val="accent1"/>
+          </a:lnRef>
+          <a:fillRef idx="3">
+            <a:schemeClr val="accent1"/>
+          </a:fillRef>
+          <a:effectRef idx="2">
+            <a:schemeClr val="accent1"/>
+          </a:effectRef>
+          <a:fontRef idx="minor">
+            <a:schemeClr val="lt1"/>
+          </a:fontRef>
+        </p:style>
+        <p:txBody>
+          <a:bodyPr rtlCol="0" anchor="ctr"/>
+          <a:lstStyle/>
+          <a:p>
+            <a:pPr algn="ctr"/>
+          </a:p>
+        </p:txBody>
+      </p:sp>
+      <p:sp>
+        <p:nvSpPr>
+          <p:cNvPr id="10" name="TextBox 9"/>
+          <p:cNvSpPr txBox="1"/>
+          <p:nvPr/>
+        </p:nvSpPr>
+        <p:spPr>
+          <a:xfrm>
+            <a:off x="4490618" y="1783080"/>
+            <a:ext cx="3210458" cy="457200"/>
+          </a:xfrm>
+          <a:prstGeom prst="rect">
+            <a:avLst/>
+          </a:prstGeom>
+          <a:noFill/>
+        </p:spPr>
+        <p:txBody>
+          <a:bodyPr wrap="square">
+            <a:spAutoFit/>
+          </a:bodyPr>
+          <a:lstStyle/>
+          <a:p>
+            <a:r>
+              <a:rPr sz="1200" b="0">
+                <a:solidFill>
+                  <a:srgbClr val="5F6F63"/>
+                </a:solidFill>
+                <a:latin typeface="Arial"/>
+              </a:rPr>
+              <a:t>Technician time charged, October</a:t>
+            </a:r>
+          </a:p>
+        </p:txBody>
+      </p:sp>
+      <p:sp>
+        <p:nvSpPr>
+          <p:cNvPr id="11" name="TextBox 10"/>
+          <p:cNvSpPr txBox="1"/>
+          <p:nvPr/>
+        </p:nvSpPr>
+        <p:spPr>
+          <a:xfrm>
+            <a:off x="4490618" y="2240280"/>
+            <a:ext cx="3210458" cy="731520"/>
+          </a:xfrm>
+          <a:prstGeom prst="rect">
+            <a:avLst/>
+          </a:prstGeom>
+          <a:noFill/>
+        </p:spPr>
+        <p:txBody>
+          <a:bodyPr wrap="square">
+            <a:spAutoFit/>
+          </a:bodyPr>
+          <a:lstStyle/>
+          <a:p>
+            <a:r>
+              <a:rPr sz="3000" b="1">
+                <a:solidFill>
+                  <a:srgbClr val="2F7A5D"/>
+                </a:solidFill>
+                <a:latin typeface="Arial"/>
+              </a:rPr>
+              <a:t>$15,005</a:t>
+            </a:r>
+          </a:p>
+        </p:txBody>
+      </p:sp>
+      <p:sp>
+        <p:nvSpPr>
+          <p:cNvPr id="12" name="TextBox 11"/>
+          <p:cNvSpPr txBox="1"/>
+          <p:nvPr/>
+        </p:nvSpPr>
+        <p:spPr>
+          <a:xfrm>
+            <a:off x="4490618" y="3017520"/>
+            <a:ext cx="3210458" cy="548640"/>
+          </a:xfrm>
+          <a:prstGeom prst="rect">
+            <a:avLst/>
+          </a:prstGeom>
+          <a:noFill/>
+        </p:spPr>
+        <p:txBody>
+          <a:bodyPr wrap="square">
+            <a:spAutoFit/>
+          </a:bodyPr>
+          <a:lstStyle/>
+          <a:p>
+            <a:r>
+              <a:rPr sz="1100" b="0">
+                <a:solidFill>
+                  <a:srgbClr val="5F6F63"/>
+                </a:solidFill>
+                <a:latin typeface="Arial"/>
+              </a:rPr>
+              <a:t>67.3% of call-out revenue</a:t>
+            </a:r>
+          </a:p>
+        </p:txBody>
+      </p:sp>
+      <p:sp>
+        <p:nvSpPr>
+          <p:cNvPr id="13" name="Rectangle 12"/>
+          <p:cNvSpPr/>
+          <p:nvPr/>
+        </p:nvSpPr>
+        <p:spPr>
+          <a:xfrm>
+            <a:off x="8158276" y="1645920"/>
+            <a:ext cx="3576218" cy="2011680"/>
+          </a:xfrm>
+          <a:prstGeom prst="rect">
+            <a:avLst/>
+          </a:prstGeom>
+          <a:solidFill>
+            <a:srgbClr val="F7FAF7"/>
+          </a:solidFill>
+          <a:ln>
+            <a:solidFill>
+              <a:srgbClr val="DCE8DC"/>
+            </a:solidFill>
+          </a:ln>
+        </p:spPr>
+        <p:style>
+          <a:lnRef idx="1">
+            <a:schemeClr val="accent1"/>
+          </a:lnRef>
+          <a:fillRef idx="3">
+            <a:schemeClr val="accent1"/>
+          </a:fillRef>
+          <a:effectRef idx="2">
+            <a:schemeClr val="accent1"/>
+          </a:effectRef>
+          <a:fontRef idx="minor">
+            <a:schemeClr val="lt1"/>
+          </a:fontRef>
+        </p:style>
+        <p:txBody>
+          <a:bodyPr rtlCol="0" anchor="ctr"/>
+          <a:lstStyle/>
+          <a:p>
+            <a:pPr algn="ctr"/>
+          </a:p>
+        </p:txBody>
+      </p:sp>
+      <p:sp>
+        <p:nvSpPr>
+          <p:cNvPr id="14" name="TextBox 13"/>
+          <p:cNvSpPr txBox="1"/>
+          <p:nvPr/>
+        </p:nvSpPr>
+        <p:spPr>
+          <a:xfrm>
+            <a:off x="8341156" y="1783080"/>
+            <a:ext cx="3210458" cy="457200"/>
+          </a:xfrm>
+          <a:prstGeom prst="rect">
+            <a:avLst/>
+          </a:prstGeom>
+          <a:noFill/>
+        </p:spPr>
+        <p:txBody>
+          <a:bodyPr wrap="square">
+            <a:spAutoFit/>
+          </a:bodyPr>
+          <a:lstStyle/>
+          <a:p>
+            <a:r>
+              <a:rPr sz="1200" b="0">
+                <a:solidFill>
+                  <a:srgbClr val="5F6F63"/>
+                </a:solidFill>
+                <a:latin typeface="Arial"/>
+              </a:rPr>
+              <a:t>Materials charged, October</a:t>
+            </a:r>
+          </a:p>
+        </p:txBody>
+      </p:sp>
+      <p:sp>
+        <p:nvSpPr>
+          <p:cNvPr id="15" name="TextBox 14"/>
+          <p:cNvSpPr txBox="1"/>
+          <p:nvPr/>
+        </p:nvSpPr>
+        <p:spPr>
+          <a:xfrm>
+            <a:off x="8341156" y="2240280"/>
+            <a:ext cx="3210458" cy="731520"/>
+          </a:xfrm>
+          <a:prstGeom prst="rect">
+            <a:avLst/>
+          </a:prstGeom>
+          <a:noFill/>
+        </p:spPr>
+        <p:txBody>
+          <a:bodyPr wrap="square">
+            <a:spAutoFit/>
+          </a:bodyPr>
+          <a:lstStyle/>
+          <a:p>
+            <a:r>
+              <a:rPr sz="3000" b="1">
+                <a:solidFill>
+                  <a:srgbClr val="2F7A5D"/>
+                </a:solidFill>
+                <a:latin typeface="Arial"/>
+              </a:rPr>
+              <a:t>$7,293</a:t>
+            </a:r>
+          </a:p>
+        </p:txBody>
+      </p:sp>
+      <p:sp>
+        <p:nvSpPr>
+          <p:cNvPr id="16" name="TextBox 15"/>
+          <p:cNvSpPr txBox="1"/>
+          <p:nvPr/>
+        </p:nvSpPr>
+        <p:spPr>
+          <a:xfrm>
+            <a:off x="8341156" y="3017520"/>
+            <a:ext cx="3210458" cy="548640"/>
+          </a:xfrm>
+          <a:prstGeom prst="rect">
+            <a:avLst/>
+          </a:prstGeom>
+          <a:noFill/>
+        </p:spPr>
+        <p:txBody>
+          <a:bodyPr wrap="square">
+            <a:spAutoFit/>
+          </a:bodyPr>
+          <a:lstStyle/>
+          <a:p>
+            <a:r>
+              <a:rPr sz="1100" b="0">
+                <a:solidFill>
+                  <a:srgbClr val="5F6F63"/>
+                </a:solidFill>
+                <a:latin typeface="Arial"/>
+              </a:rPr>
+              <a:t>$5,610 at cost, plus 30%</a:t>
+            </a:r>
+          </a:p>
+        </p:txBody>
+      </p:sp>
+      <p:sp>
+        <p:nvSpPr>
+          <p:cNvPr id="17" name="TextBox 16"/>
           <p:cNvSpPr txBox="1"/>
           <p:nvPr/>
         </p:nvSpPr>
@@ -8138,7 +8432,7 @@
       </p:sp>
       <p:sp>
         <p:nvSpPr>
-          <p:cNvPr id="10" name="TextBox 9"/>
+          <p:cNvPr id="18" name="TextBox 17"/>
           <p:cNvSpPr txBox="1"/>
           <p:nvPr/>
         </p:nvSpPr>
@@ -8173,7 +8467,7 @@
       </p:sp>
       <p:sp>
         <p:nvSpPr>
-          <p:cNvPr id="11" name="TextBox 10"/>
+          <p:cNvPr id="19" name="TextBox 18"/>
           <p:cNvSpPr txBox="1"/>
           <p:nvPr/>
         </p:nvSpPr>
@@ -9047,7 +9341,7 @@
                 </a:solidFill>
                 <a:latin typeface="Arial"/>
               </a:rPr>
-              <a:t>43 call-outs in October made a 43.3% job gross margin between them. Gross margins run from 37.8% to 45.9% by length: the hourly rate covers technician time comfortably, so the gross margin mostly moves with how much material goes on the van.</a:t>
+              <a:t>43 call-outs in October billed $15,005 of technician time and $7,293 of materials ($5,610 at cost plus 30%), and made a 43.3% job gross margin between them. Gross margins run from 37.8% to 45.9% by length: the hourly rate covers technician time comfortably, so the gross margin mostly moves with how much material goes on the van.</a:t>
             </a:r>
           </a:p>
         </p:txBody>

</xml_diff>